<commit_message>
Translate efficiency slide to English
Slide text, number format (comma thousands) and unambiguous dates
(12 Jan 2026) switched to English; data.json input format unchanged.

Co-Authored-By: Claude Opus 5.5 <noreply@anthropic.com>
Claude-Session: https://claude.ai/code/session_01QVNYX9hqrFkr7H6xVsCVvt
</commit_message>
<xml_diff>
--- a/slide-efficientamento/efficientamento_stream.pptx
+++ b/slide-efficientamento/efficientamento_stream.pptx
@@ -877,7 +877,7 @@
       </p:grpSpPr>
       <p:sp>
         <p:nvSpPr>
-          <p:cNvPr id="2" name="Titolo"/>
+          <p:cNvPr id="2" name="Title"/>
           <p:cNvSpPr txBox="1"/>
           <p:nvPr/>
         </p:nvSpPr>
@@ -908,7 +908,7 @@
                 <a:ea typeface="Calibri" pitchFamily="34" charset="-122"/>
                 <a:cs typeface="Calibri" pitchFamily="34" charset="-120"/>
               </a:rPr>
-              <a:t>Eliminati [n.d.] elementi non più necessari: da [n.d.] a [n.d.] sui tre stream</a:t>
+              <a:t>[n/a] redundant items removed: from [n/a] to [n/a] across 3 streams</a:t>
             </a:r>
             <a:endParaRPr lang="en-US" sz="2600" dirty="0"/>
           </a:p>
@@ -916,7 +916,7 @@
       </p:sp>
       <p:sp>
         <p:nvSpPr>
-          <p:cNvPr id="3" name="Sottotitolo"/>
+          <p:cNvPr id="3" name="Subtitle"/>
           <p:cNvSpPr txBox="1"/>
           <p:nvPr/>
         </p:nvSpPr>
@@ -947,7 +947,7 @@
                 <a:ea typeface="Calibri" pitchFamily="34" charset="-122"/>
                 <a:cs typeface="Calibri" pitchFamily="34" charset="-120"/>
               </a:rPr>
-              <a:t>Numerica degli elementi per stream prima e dopo l'attività di analisi</a:t>
+              <a:t>Number of items per stream, before and after the analysis</a:t>
             </a:r>
             <a:endParaRPr lang="en-US" sz="1400" dirty="0"/>
           </a:p>
@@ -955,7 +955,7 @@
       </p:sp>
       <p:sp>
         <p:nvSpPr>
-          <p:cNvPr id="4" name="KPI Situazione iniziale"/>
+          <p:cNvPr id="4" name="KPI Baseline"/>
           <p:cNvSpPr/>
           <p:nvPr/>
         </p:nvSpPr>
@@ -1028,7 +1028,7 @@
                 <a:ea typeface="Calibri" pitchFamily="34" charset="-122"/>
                 <a:cs typeface="Calibri" pitchFamily="34" charset="-120"/>
               </a:rPr>
-              <a:t>SITUAZIONE INIZIALE</a:t>
+              <a:t>BASELINE</a:t>
             </a:r>
             <a:endParaRPr lang="en-US" sz="1200" dirty="0"/>
           </a:p>
@@ -1067,7 +1067,7 @@
                 <a:ea typeface="Calibri" pitchFamily="34" charset="-122"/>
                 <a:cs typeface="Calibri" pitchFamily="34" charset="-120"/>
               </a:rPr>
-              <a:t>n.d.</a:t>
+              <a:t>n/a</a:t>
             </a:r>
             <a:endParaRPr lang="en-US" sz="3400" dirty="0"/>
           </a:p>
@@ -1114,7 +1114,7 @@
       </p:sp>
       <p:sp>
         <p:nvSpPr>
-          <p:cNvPr id="9" name="KPI Elementi eliminati"/>
+          <p:cNvPr id="9" name="KPI Items removed"/>
           <p:cNvSpPr/>
           <p:nvPr/>
         </p:nvSpPr>
@@ -1187,7 +1187,7 @@
                 <a:ea typeface="Calibri" pitchFamily="34" charset="-122"/>
                 <a:cs typeface="Calibri" pitchFamily="34" charset="-120"/>
               </a:rPr>
-              <a:t>ELEMENTI ELIMINATI</a:t>
+              <a:t>ITEMS REMOVED</a:t>
             </a:r>
             <a:endParaRPr lang="en-US" sz="1200" dirty="0"/>
           </a:p>
@@ -1226,7 +1226,7 @@
                 <a:ea typeface="Calibri" pitchFamily="34" charset="-122"/>
                 <a:cs typeface="Calibri" pitchFamily="34" charset="-120"/>
               </a:rPr>
-              <a:t>n.d.</a:t>
+              <a:t>n/a</a:t>
             </a:r>
             <a:endParaRPr lang="en-US" sz="3400" dirty="0"/>
           </a:p>
@@ -1273,7 +1273,7 @@
       </p:sp>
       <p:sp>
         <p:nvSpPr>
-          <p:cNvPr id="14" name="KPI Situazione finale"/>
+          <p:cNvPr id="14" name="KPI Final state"/>
           <p:cNvSpPr/>
           <p:nvPr/>
         </p:nvSpPr>
@@ -1346,7 +1346,7 @@
                 <a:ea typeface="Calibri" pitchFamily="34" charset="-122"/>
                 <a:cs typeface="Calibri" pitchFamily="34" charset="-120"/>
               </a:rPr>
-              <a:t>SITUAZIONE FINALE</a:t>
+              <a:t>FINAL STATE</a:t>
             </a:r>
             <a:endParaRPr lang="en-US" sz="1200" dirty="0"/>
           </a:p>
@@ -1385,7 +1385,7 @@
                 <a:ea typeface="Calibri" pitchFamily="34" charset="-122"/>
                 <a:cs typeface="Calibri" pitchFamily="34" charset="-120"/>
               </a:rPr>
-              <a:t>n.d.</a:t>
+              <a:t>n/a</a:t>
             </a:r>
             <a:endParaRPr lang="en-US" sz="3400" dirty="0"/>
           </a:p>
@@ -1424,7 +1424,7 @@
                 <a:ea typeface="Calibri" pitchFamily="34" charset="-122"/>
                 <a:cs typeface="Calibri" pitchFamily="34" charset="-120"/>
               </a:rPr>
-              <a:t>CONFRONTO PER STREAM</a:t>
+              <a:t>BREAKDOWN BY STREAM</a:t>
             </a:r>
             <a:endParaRPr lang="en-US" sz="1200" dirty="0"/>
           </a:p>
@@ -1463,7 +1463,7 @@
                 <a:ea typeface="Calibri" pitchFamily="34" charset="-122"/>
                 <a:cs typeface="Calibri" pitchFamily="34" charset="-120"/>
               </a:rPr>
-              <a:t>PERIODO DI ATTIVITÀ</a:t>
+              <a:t>ACTIVITY PERIOD</a:t>
             </a:r>
             <a:endParaRPr lang="en-US" sz="1200" dirty="0"/>
           </a:p>
@@ -1524,7 +1524,7 @@
                 <a:ea typeface="Calibri" pitchFamily="34" charset="-122"/>
                 <a:cs typeface="Calibri" pitchFamily="34" charset="-120"/>
               </a:rPr>
-              <a:t>Iniziale</a:t>
+              <a:t>Baseline</a:t>
             </a:r>
             <a:endParaRPr lang="en-US" sz="1200" dirty="0"/>
           </a:p>
@@ -1585,7 +1585,7 @@
                 <a:ea typeface="Calibri" pitchFamily="34" charset="-122"/>
                 <a:cs typeface="Calibri" pitchFamily="34" charset="-120"/>
               </a:rPr>
-              <a:t>Eliminati</a:t>
+              <a:t>Removed</a:t>
             </a:r>
             <a:endParaRPr lang="en-US" sz="1200" dirty="0"/>
           </a:p>
@@ -1646,7 +1646,7 @@
                 <a:ea typeface="Calibri" pitchFamily="34" charset="-122"/>
                 <a:cs typeface="Calibri" pitchFamily="34" charset="-120"/>
               </a:rPr>
-              <a:t>Finale</a:t>
+              <a:t>Final</a:t>
             </a:r>
             <a:endParaRPr lang="en-US" sz="1200" dirty="0"/>
           </a:p>
@@ -1770,7 +1770,7 @@
                 <a:ea typeface="Calibri" pitchFamily="34" charset="-122"/>
                 <a:cs typeface="Calibri" pitchFamily="34" charset="-120"/>
               </a:rPr>
-              <a:t>n.d. eliminati</a:t>
+              <a:t>n/a removed</a:t>
             </a:r>
             <a:endParaRPr lang="en-US" sz="1300" dirty="0"/>
           </a:p>
@@ -1778,7 +1778,7 @@
       </p:sp>
       <p:sp>
         <p:nvSpPr>
-          <p:cNvPr id="30" name="Stream 1 iniziale"/>
+          <p:cNvPr id="30" name="Stream 1 baseline"/>
           <p:cNvSpPr/>
           <p:nvPr/>
         </p:nvSpPr>
@@ -1800,7 +1800,7 @@
       </p:sp>
       <p:sp>
         <p:nvSpPr>
-          <p:cNvPr id="31" name="Stream 1 finale"/>
+          <p:cNvPr id="31" name="Stream 1 final"/>
           <p:cNvSpPr/>
           <p:nvPr/>
         </p:nvSpPr>
@@ -1822,7 +1822,7 @@
       </p:sp>
       <p:sp>
         <p:nvSpPr>
-          <p:cNvPr id="32" name="Stream 1 eliminati"/>
+          <p:cNvPr id="32" name="Stream 1 removed"/>
           <p:cNvSpPr/>
           <p:nvPr/>
         </p:nvSpPr>
@@ -1878,7 +1878,7 @@
                 <a:ea typeface="Calibri" pitchFamily="34" charset="-122"/>
                 <a:cs typeface="Calibri" pitchFamily="34" charset="-120"/>
               </a:rPr>
-              <a:t>n.d.</a:t>
+              <a:t>n/a</a:t>
             </a:r>
             <a:endParaRPr lang="en-US" sz="1400" dirty="0"/>
           </a:p>
@@ -1917,7 +1917,7 @@
                 <a:ea typeface="Calibri" pitchFamily="34" charset="-122"/>
                 <a:cs typeface="Calibri" pitchFamily="34" charset="-120"/>
               </a:rPr>
-              <a:t>n.d.</a:t>
+              <a:t>n/a</a:t>
             </a:r>
             <a:endParaRPr lang="en-US" sz="1600" dirty="0"/>
           </a:p>
@@ -1925,7 +1925,7 @@
       </p:sp>
       <p:sp>
         <p:nvSpPr>
-          <p:cNvPr id="35" name="Stream 1 periodo"/>
+          <p:cNvPr id="35" name="Stream 1 period"/>
           <p:cNvSpPr/>
           <p:nvPr/>
         </p:nvSpPr>
@@ -1978,7 +1978,7 @@
                 <a:ea typeface="Calibri" pitchFamily="34" charset="-122"/>
                 <a:cs typeface="Calibri" pitchFamily="34" charset="-120"/>
               </a:rPr>
-              <a:t>gg/mm/aaaa – gg/mm/aaaa</a:t>
+              <a:t>dd Mmm yyyy – dd Mmm yyyy</a:t>
             </a:r>
             <a:endParaRPr lang="en-US" sz="1200" dirty="0"/>
           </a:p>
@@ -2079,7 +2079,7 @@
                 <a:ea typeface="Calibri" pitchFamily="34" charset="-122"/>
                 <a:cs typeface="Calibri" pitchFamily="34" charset="-120"/>
               </a:rPr>
-              <a:t>n.d. eliminati</a:t>
+              <a:t>n/a removed</a:t>
             </a:r>
             <a:endParaRPr lang="en-US" sz="1300" dirty="0"/>
           </a:p>
@@ -2087,7 +2087,7 @@
       </p:sp>
       <p:sp>
         <p:nvSpPr>
-          <p:cNvPr id="40" name="Stream 2 iniziale"/>
+          <p:cNvPr id="40" name="Stream 2 baseline"/>
           <p:cNvSpPr/>
           <p:nvPr/>
         </p:nvSpPr>
@@ -2109,7 +2109,7 @@
       </p:sp>
       <p:sp>
         <p:nvSpPr>
-          <p:cNvPr id="41" name="Stream 2 finale"/>
+          <p:cNvPr id="41" name="Stream 2 final"/>
           <p:cNvSpPr/>
           <p:nvPr/>
         </p:nvSpPr>
@@ -2131,7 +2131,7 @@
       </p:sp>
       <p:sp>
         <p:nvSpPr>
-          <p:cNvPr id="42" name="Stream 2 eliminati"/>
+          <p:cNvPr id="42" name="Stream 2 removed"/>
           <p:cNvSpPr/>
           <p:nvPr/>
         </p:nvSpPr>
@@ -2187,7 +2187,7 @@
                 <a:ea typeface="Calibri" pitchFamily="34" charset="-122"/>
                 <a:cs typeface="Calibri" pitchFamily="34" charset="-120"/>
               </a:rPr>
-              <a:t>n.d.</a:t>
+              <a:t>n/a</a:t>
             </a:r>
             <a:endParaRPr lang="en-US" sz="1400" dirty="0"/>
           </a:p>
@@ -2226,7 +2226,7 @@
                 <a:ea typeface="Calibri" pitchFamily="34" charset="-122"/>
                 <a:cs typeface="Calibri" pitchFamily="34" charset="-120"/>
               </a:rPr>
-              <a:t>n.d.</a:t>
+              <a:t>n/a</a:t>
             </a:r>
             <a:endParaRPr lang="en-US" sz="1600" dirty="0"/>
           </a:p>
@@ -2234,7 +2234,7 @@
       </p:sp>
       <p:sp>
         <p:nvSpPr>
-          <p:cNvPr id="45" name="Stream 2 periodo"/>
+          <p:cNvPr id="45" name="Stream 2 period"/>
           <p:cNvSpPr/>
           <p:nvPr/>
         </p:nvSpPr>
@@ -2287,7 +2287,7 @@
                 <a:ea typeface="Calibri" pitchFamily="34" charset="-122"/>
                 <a:cs typeface="Calibri" pitchFamily="34" charset="-120"/>
               </a:rPr>
-              <a:t>gg/mm/aaaa – gg/mm/aaaa</a:t>
+              <a:t>dd Mmm yyyy – dd Mmm yyyy</a:t>
             </a:r>
             <a:endParaRPr lang="en-US" sz="1200" dirty="0"/>
           </a:p>
@@ -2388,7 +2388,7 @@
                 <a:ea typeface="Calibri" pitchFamily="34" charset="-122"/>
                 <a:cs typeface="Calibri" pitchFamily="34" charset="-120"/>
               </a:rPr>
-              <a:t>n.d. eliminati</a:t>
+              <a:t>n/a removed</a:t>
             </a:r>
             <a:endParaRPr lang="en-US" sz="1300" dirty="0"/>
           </a:p>
@@ -2396,7 +2396,7 @@
       </p:sp>
       <p:sp>
         <p:nvSpPr>
-          <p:cNvPr id="50" name="Stream 3 iniziale"/>
+          <p:cNvPr id="50" name="Stream 3 baseline"/>
           <p:cNvSpPr/>
           <p:nvPr/>
         </p:nvSpPr>
@@ -2418,7 +2418,7 @@
       </p:sp>
       <p:sp>
         <p:nvSpPr>
-          <p:cNvPr id="51" name="Stream 3 finale"/>
+          <p:cNvPr id="51" name="Stream 3 final"/>
           <p:cNvSpPr/>
           <p:nvPr/>
         </p:nvSpPr>
@@ -2440,7 +2440,7 @@
       </p:sp>
       <p:sp>
         <p:nvSpPr>
-          <p:cNvPr id="52" name="Stream 3 eliminati"/>
+          <p:cNvPr id="52" name="Stream 3 removed"/>
           <p:cNvSpPr/>
           <p:nvPr/>
         </p:nvSpPr>
@@ -2496,7 +2496,7 @@
                 <a:ea typeface="Calibri" pitchFamily="34" charset="-122"/>
                 <a:cs typeface="Calibri" pitchFamily="34" charset="-120"/>
               </a:rPr>
-              <a:t>n.d.</a:t>
+              <a:t>n/a</a:t>
             </a:r>
             <a:endParaRPr lang="en-US" sz="1400" dirty="0"/>
           </a:p>
@@ -2535,7 +2535,7 @@
                 <a:ea typeface="Calibri" pitchFamily="34" charset="-122"/>
                 <a:cs typeface="Calibri" pitchFamily="34" charset="-120"/>
               </a:rPr>
-              <a:t>n.d.</a:t>
+              <a:t>n/a</a:t>
             </a:r>
             <a:endParaRPr lang="en-US" sz="1600" dirty="0"/>
           </a:p>
@@ -2543,7 +2543,7 @@
       </p:sp>
       <p:sp>
         <p:nvSpPr>
-          <p:cNvPr id="55" name="Stream 3 periodo"/>
+          <p:cNvPr id="55" name="Stream 3 period"/>
           <p:cNvSpPr/>
           <p:nvPr/>
         </p:nvSpPr>
@@ -2596,7 +2596,7 @@
                 <a:ea typeface="Calibri" pitchFamily="34" charset="-122"/>
                 <a:cs typeface="Calibri" pitchFamily="34" charset="-120"/>
               </a:rPr>
-              <a:t>gg/mm/aaaa – gg/mm/aaaa</a:t>
+              <a:t>dd Mmm yyyy – dd Mmm yyyy</a:t>
             </a:r>
             <a:endParaRPr lang="en-US" sz="1200" dirty="0"/>
           </a:p>
@@ -2635,7 +2635,7 @@
                 <a:ea typeface="Calibri" pitchFamily="34" charset="-122"/>
                 <a:cs typeface="Calibri" pitchFamily="34" charset="-120"/>
               </a:rPr>
-              <a:t>Elementi eliminati = numerica iniziale − numerica finale. Totali calcolati come somma dei tre stream.</a:t>
+              <a:t>Items removed = baseline − final count. Totals are the sum of the three streams.</a:t>
             </a:r>
             <a:endParaRPr lang="en-US" sz="1000" dirty="0"/>
           </a:p>
@@ -2674,7 +2674,7 @@
                 <a:ea typeface="Calibri" pitchFamily="34" charset="-122"/>
                 <a:cs typeface="Calibri" pitchFamily="34" charset="-120"/>
               </a:rPr>
-              <a:t>TEMPLATE – dati da inserire in data.json</a:t>
+              <a:t>TEMPLATE – data to be entered in data.json</a:t>
             </a:r>
             <a:endParaRPr lang="en-US" sz="1000" dirty="0"/>
           </a:p>

</xml_diff>